<commit_message>
Polish final presentation visual layout
</commit_message>
<xml_diff>
--- a/presentation.pptx
+++ b/presentation.pptx
@@ -16,7 +16,7 @@
     <p:sldId id="264" r:id="rId15"/>
     <p:sldId id="265" r:id="rId16"/>
   </p:sldIdLst>
-  <p:sldSz cx="12191999" cy="6858000" type="screen4x3"/>
+  <p:sldSz cx="12191695" cy="6858000" type="screen4x3"/>
   <p:notesSz cx="6858000" cy="9144000"/>
   <p:defaultTextStyle>
     <a:defPPr>
@@ -3114,7 +3114,7 @@
         <p:spPr>
           <a:xfrm>
             <a:off x="0" y="0"/>
-            <a:ext cx="12191999" cy="6858000"/>
+            <a:ext cx="12191695" cy="6858000"/>
           </a:xfrm>
           <a:prstGeom prst="rect">
             <a:avLst/>
@@ -3156,7 +3156,7 @@
         <p:spPr>
           <a:xfrm>
             <a:off x="0" y="0"/>
-            <a:ext cx="12191999" cy="6858000"/>
+            <a:ext cx="12191695" cy="6858000"/>
           </a:xfrm>
           <a:prstGeom prst="rect">
             <a:avLst/>
@@ -3198,7 +3198,7 @@
         <p:spPr>
           <a:xfrm>
             <a:off x="0" y="0"/>
-            <a:ext cx="12191999" cy="6858000"/>
+            <a:ext cx="12191695" cy="6858000"/>
           </a:xfrm>
           <a:prstGeom prst="rect">
             <a:avLst/>
@@ -3240,7 +3240,7 @@
         <p:spPr>
           <a:xfrm>
             <a:off x="0" y="0"/>
-            <a:ext cx="12191999" cy="6858000"/>
+            <a:ext cx="12191695" cy="6858000"/>
           </a:xfrm>
           <a:prstGeom prst="rect">
             <a:avLst/>
@@ -3282,7 +3282,7 @@
         <p:spPr>
           <a:xfrm>
             <a:off x="0" y="0"/>
-            <a:ext cx="12191999" cy="6858000"/>
+            <a:ext cx="12191695" cy="6858000"/>
           </a:xfrm>
           <a:prstGeom prst="rect">
             <a:avLst/>
@@ -3324,7 +3324,7 @@
         <p:spPr>
           <a:xfrm>
             <a:off x="0" y="0"/>
-            <a:ext cx="12191999" cy="6858000"/>
+            <a:ext cx="12191695" cy="6858000"/>
           </a:xfrm>
           <a:prstGeom prst="rect">
             <a:avLst/>
@@ -3366,7 +3366,7 @@
         <p:spPr>
           <a:xfrm>
             <a:off x="0" y="0"/>
-            <a:ext cx="12191999" cy="6858000"/>
+            <a:ext cx="12191695" cy="6858000"/>
           </a:xfrm>
           <a:prstGeom prst="rect">
             <a:avLst/>
@@ -3408,7 +3408,7 @@
         <p:spPr>
           <a:xfrm>
             <a:off x="0" y="0"/>
-            <a:ext cx="12191999" cy="6858000"/>
+            <a:ext cx="12191695" cy="6858000"/>
           </a:xfrm>
           <a:prstGeom prst="rect">
             <a:avLst/>
@@ -3450,7 +3450,7 @@
         <p:spPr>
           <a:xfrm>
             <a:off x="0" y="0"/>
-            <a:ext cx="12191999" cy="6858000"/>
+            <a:ext cx="12191695" cy="6858000"/>
           </a:xfrm>
           <a:prstGeom prst="rect">
             <a:avLst/>
@@ -3492,7 +3492,7 @@
         <p:spPr>
           <a:xfrm>
             <a:off x="0" y="0"/>
-            <a:ext cx="12191999" cy="6858000"/>
+            <a:ext cx="12191695" cy="6858000"/>
           </a:xfrm>
           <a:prstGeom prst="rect">
             <a:avLst/>

</xml_diff>